<commit_message>
Update PPTX: 9 slides with team members
Co-Authored-By: Claude Opus 5.5 <noreply@anthropic.com>
</commit_message>
<xml_diff>
--- a/docs/presentation/ResearchAI_Review1.pptx
+++ b/docs/presentation/ResearchAI_Review1.pptx
@@ -13,6 +13,7 @@
     <p:sldId id="261" r:id="rId12"/>
     <p:sldId id="262" r:id="rId13"/>
     <p:sldId id="263" r:id="rId14"/>
+    <p:sldId id="264" r:id="rId15"/>
   </p:sldIdLst>
   <p:sldSz cx="12191695" cy="6858000" type="screen4x3"/>
   <p:notesSz cx="6858000" cy="9144000"/>
@@ -3365,8 +3366,8 @@
         </p:nvSpPr>
         <p:spPr>
           <a:xfrm>
-            <a:off x="731520" y="5074920"/>
-            <a:ext cx="5852160" cy="1097280"/>
+            <a:off x="731520" y="5257800"/>
+            <a:ext cx="5852160" cy="914400"/>
           </a:xfrm>
           <a:prstGeom prst="rect">
             <a:avLst/>
@@ -3378,22 +3379,6 @@
             <a:spAutoFit/>
           </a:bodyPr>
           <a:lstStyle/>
-          <a:p>
-            <a:pPr algn="l">
-              <a:spcAft>
-                <a:spcPts val="400"/>
-              </a:spcAft>
-            </a:pPr>
-            <a:r>
-              <a:rPr sz="1800" b="1">
-                <a:solidFill>
-                  <a:srgbClr val="FFFFFF"/>
-                </a:solidFill>
-                <a:latin typeface="Segoe UI"/>
-              </a:rPr>
-              <a:t>Keshav Tomar</a:t>
-            </a:r>
-          </a:p>
           <a:p>
             <a:pPr algn="l">
               <a:spcAft>
@@ -3444,7 +3429,7 @@
         </p:blipFill>
         <p:spPr>
           <a:xfrm>
-            <a:off x="6766560" y="1234440"/>
+            <a:off x="6766560" y="914400"/>
             <a:ext cx="5029200" cy="3143250"/>
           </a:xfrm>
           <a:prstGeom prst="rect">
@@ -3452,6 +3437,375 @@
           </a:prstGeom>
         </p:spPr>
       </p:pic>
+      <p:sp>
+        <p:nvSpPr>
+          <p:cNvPr id="10" name="Rounded Rectangle 9"/>
+          <p:cNvSpPr/>
+          <p:nvPr/>
+        </p:nvSpPr>
+        <p:spPr>
+          <a:xfrm>
+            <a:off x="6766560" y="4343400"/>
+            <a:ext cx="5029200" cy="1965960"/>
+          </a:xfrm>
+          <a:prstGeom prst="roundRect">
+            <a:avLst>
+              <a:gd name="adj" fmla="val 8000"/>
+            </a:avLst>
+          </a:prstGeom>
+          <a:solidFill>
+            <a:srgbClr val="242255"/>
+          </a:solidFill>
+          <a:ln w="15875">
+            <a:solidFill>
+              <a:srgbClr val="3A3680"/>
+            </a:solidFill>
+          </a:ln>
+          <a:effectLst/>
+        </p:spPr>
+        <p:style>
+          <a:lnRef idx="1">
+            <a:schemeClr val="accent1"/>
+          </a:lnRef>
+          <a:fillRef idx="3">
+            <a:schemeClr val="accent1"/>
+          </a:fillRef>
+          <a:effectRef idx="2">
+            <a:schemeClr val="accent1"/>
+          </a:effectRef>
+          <a:fontRef idx="minor">
+            <a:schemeClr val="lt1"/>
+          </a:fontRef>
+        </p:style>
+        <p:txBody>
+          <a:bodyPr rtlCol="0" anchor="ctr"/>
+          <a:lstStyle/>
+          <a:p>
+            <a:pPr algn="ctr"/>
+          </a:p>
+        </p:txBody>
+      </p:sp>
+      <p:sp>
+        <p:nvSpPr>
+          <p:cNvPr id="11" name="TextBox 10"/>
+          <p:cNvSpPr txBox="1"/>
+          <p:nvPr/>
+        </p:nvSpPr>
+        <p:spPr>
+          <a:xfrm>
+            <a:off x="7040880" y="4498848"/>
+            <a:ext cx="4572000" cy="320040"/>
+          </a:xfrm>
+          <a:prstGeom prst="rect">
+            <a:avLst/>
+          </a:prstGeom>
+          <a:noFill/>
+        </p:spPr>
+        <p:txBody>
+          <a:bodyPr wrap="square" anchor="t" lIns="45720" rIns="45720">
+            <a:spAutoFit/>
+          </a:bodyPr>
+          <a:lstStyle/>
+          <a:p>
+            <a:pPr algn="l">
+              <a:spcAft>
+                <a:spcPts val="400"/>
+              </a:spcAft>
+            </a:pPr>
+            <a:r>
+              <a:rPr sz="1200" b="1">
+                <a:solidFill>
+                  <a:srgbClr val="B6B0FF"/>
+                </a:solidFill>
+                <a:latin typeface="Segoe UI"/>
+              </a:rPr>
+              <a:t>TEAM</a:t>
+            </a:r>
+          </a:p>
+        </p:txBody>
+      </p:sp>
+      <p:sp>
+        <p:nvSpPr>
+          <p:cNvPr id="12" name="TextBox 11"/>
+          <p:cNvSpPr txBox="1"/>
+          <p:nvPr/>
+        </p:nvSpPr>
+        <p:spPr>
+          <a:xfrm>
+            <a:off x="7040880" y="4864608"/>
+            <a:ext cx="3017520" cy="411480"/>
+          </a:xfrm>
+          <a:prstGeom prst="rect">
+            <a:avLst/>
+          </a:prstGeom>
+          <a:noFill/>
+        </p:spPr>
+        <p:txBody>
+          <a:bodyPr wrap="square" anchor="t" lIns="45720" rIns="45720">
+            <a:spAutoFit/>
+          </a:bodyPr>
+          <a:lstStyle/>
+          <a:p>
+            <a:pPr algn="l">
+              <a:spcAft>
+                <a:spcPts val="400"/>
+              </a:spcAft>
+            </a:pPr>
+            <a:r>
+              <a:rPr sz="1700" b="1">
+                <a:solidFill>
+                  <a:srgbClr val="FFFFFF"/>
+                </a:solidFill>
+                <a:latin typeface="Segoe UI"/>
+              </a:rPr>
+              <a:t>Keshav Tomar</a:t>
+            </a:r>
+          </a:p>
+        </p:txBody>
+      </p:sp>
+      <p:sp>
+        <p:nvSpPr>
+          <p:cNvPr id="13" name="Rounded Rectangle 12"/>
+          <p:cNvSpPr/>
+          <p:nvPr/>
+        </p:nvSpPr>
+        <p:spPr>
+          <a:xfrm>
+            <a:off x="10058400" y="4901184"/>
+            <a:ext cx="1508760" cy="329184"/>
+          </a:xfrm>
+          <a:prstGeom prst="roundRect">
+            <a:avLst>
+              <a:gd name="adj" fmla="val 50000"/>
+            </a:avLst>
+          </a:prstGeom>
+          <a:solidFill>
+            <a:srgbClr val="6257F5"/>
+          </a:solidFill>
+          <a:ln>
+            <a:noFill/>
+          </a:ln>
+          <a:effectLst/>
+        </p:spPr>
+        <p:style>
+          <a:lnRef idx="1">
+            <a:schemeClr val="accent1"/>
+          </a:lnRef>
+          <a:fillRef idx="3">
+            <a:schemeClr val="accent1"/>
+          </a:fillRef>
+          <a:effectRef idx="2">
+            <a:schemeClr val="accent1"/>
+          </a:effectRef>
+          <a:fontRef idx="minor">
+            <a:schemeClr val="lt1"/>
+          </a:fontRef>
+        </p:style>
+        <p:txBody>
+          <a:bodyPr rtlCol="0" anchor="ctr" tIns="0" bIns="0"/>
+          <a:lstStyle/>
+          <a:p>
+            <a:pPr algn="ctr"/>
+            <a:r>
+              <a:rPr sz="1050" b="1">
+                <a:solidFill>
+                  <a:srgbClr val="FFFFFF"/>
+                </a:solidFill>
+                <a:latin typeface="Segoe UI"/>
+              </a:rPr>
+              <a:t>Team Leader</a:t>
+            </a:r>
+          </a:p>
+        </p:txBody>
+      </p:sp>
+      <p:sp>
+        <p:nvSpPr>
+          <p:cNvPr id="14" name="TextBox 13"/>
+          <p:cNvSpPr txBox="1"/>
+          <p:nvPr/>
+        </p:nvSpPr>
+        <p:spPr>
+          <a:xfrm>
+            <a:off x="7040880" y="5303520"/>
+            <a:ext cx="3017520" cy="411480"/>
+          </a:xfrm>
+          <a:prstGeom prst="rect">
+            <a:avLst/>
+          </a:prstGeom>
+          <a:noFill/>
+        </p:spPr>
+        <p:txBody>
+          <a:bodyPr wrap="square" anchor="t" lIns="45720" rIns="45720">
+            <a:spAutoFit/>
+          </a:bodyPr>
+          <a:lstStyle/>
+          <a:p>
+            <a:pPr algn="l">
+              <a:spcAft>
+                <a:spcPts val="400"/>
+              </a:spcAft>
+            </a:pPr>
+            <a:r>
+              <a:rPr sz="1500" b="0">
+                <a:solidFill>
+                  <a:srgbClr val="FFFFFF"/>
+                </a:solidFill>
+                <a:latin typeface="Segoe UI"/>
+              </a:rPr>
+              <a:t>Astik Sharma</a:t>
+            </a:r>
+          </a:p>
+        </p:txBody>
+      </p:sp>
+      <p:sp>
+        <p:nvSpPr>
+          <p:cNvPr id="15" name="Rounded Rectangle 14"/>
+          <p:cNvSpPr/>
+          <p:nvPr/>
+        </p:nvSpPr>
+        <p:spPr>
+          <a:xfrm>
+            <a:off x="10058400" y="5340096"/>
+            <a:ext cx="1508760" cy="329184"/>
+          </a:xfrm>
+          <a:prstGeom prst="roundRect">
+            <a:avLst>
+              <a:gd name="adj" fmla="val 50000"/>
+            </a:avLst>
+          </a:prstGeom>
+          <a:solidFill>
+            <a:srgbClr val="343170"/>
+          </a:solidFill>
+          <a:ln>
+            <a:noFill/>
+          </a:ln>
+          <a:effectLst/>
+        </p:spPr>
+        <p:style>
+          <a:lnRef idx="1">
+            <a:schemeClr val="accent1"/>
+          </a:lnRef>
+          <a:fillRef idx="3">
+            <a:schemeClr val="accent1"/>
+          </a:fillRef>
+          <a:effectRef idx="2">
+            <a:schemeClr val="accent1"/>
+          </a:effectRef>
+          <a:fontRef idx="minor">
+            <a:schemeClr val="lt1"/>
+          </a:fontRef>
+        </p:style>
+        <p:txBody>
+          <a:bodyPr rtlCol="0" anchor="ctr" tIns="0" bIns="0"/>
+          <a:lstStyle/>
+          <a:p>
+            <a:pPr algn="ctr"/>
+            <a:r>
+              <a:rPr sz="1050" b="1">
+                <a:solidFill>
+                  <a:srgbClr val="D8D6F5"/>
+                </a:solidFill>
+                <a:latin typeface="Segoe UI"/>
+              </a:rPr>
+              <a:t>Team Member</a:t>
+            </a:r>
+          </a:p>
+        </p:txBody>
+      </p:sp>
+      <p:sp>
+        <p:nvSpPr>
+          <p:cNvPr id="16" name="TextBox 15"/>
+          <p:cNvSpPr txBox="1"/>
+          <p:nvPr/>
+        </p:nvSpPr>
+        <p:spPr>
+          <a:xfrm>
+            <a:off x="7040880" y="5742432"/>
+            <a:ext cx="3017520" cy="411480"/>
+          </a:xfrm>
+          <a:prstGeom prst="rect">
+            <a:avLst/>
+          </a:prstGeom>
+          <a:noFill/>
+        </p:spPr>
+        <p:txBody>
+          <a:bodyPr wrap="square" anchor="t" lIns="45720" rIns="45720">
+            <a:spAutoFit/>
+          </a:bodyPr>
+          <a:lstStyle/>
+          <a:p>
+            <a:pPr algn="l">
+              <a:spcAft>
+                <a:spcPts val="400"/>
+              </a:spcAft>
+            </a:pPr>
+            <a:r>
+              <a:rPr sz="1500" b="0">
+                <a:solidFill>
+                  <a:srgbClr val="FFFFFF"/>
+                </a:solidFill>
+                <a:latin typeface="Segoe UI"/>
+              </a:rPr>
+              <a:t>Shudhanshu Kumar</a:t>
+            </a:r>
+          </a:p>
+        </p:txBody>
+      </p:sp>
+      <p:sp>
+        <p:nvSpPr>
+          <p:cNvPr id="17" name="Rounded Rectangle 16"/>
+          <p:cNvSpPr/>
+          <p:nvPr/>
+        </p:nvSpPr>
+        <p:spPr>
+          <a:xfrm>
+            <a:off x="10058400" y="5779008"/>
+            <a:ext cx="1508760" cy="329184"/>
+          </a:xfrm>
+          <a:prstGeom prst="roundRect">
+            <a:avLst>
+              <a:gd name="adj" fmla="val 50000"/>
+            </a:avLst>
+          </a:prstGeom>
+          <a:solidFill>
+            <a:srgbClr val="343170"/>
+          </a:solidFill>
+          <a:ln>
+            <a:noFill/>
+          </a:ln>
+          <a:effectLst/>
+        </p:spPr>
+        <p:style>
+          <a:lnRef idx="1">
+            <a:schemeClr val="accent1"/>
+          </a:lnRef>
+          <a:fillRef idx="3">
+            <a:schemeClr val="accent1"/>
+          </a:fillRef>
+          <a:effectRef idx="2">
+            <a:schemeClr val="accent1"/>
+          </a:effectRef>
+          <a:fontRef idx="minor">
+            <a:schemeClr val="lt1"/>
+          </a:fontRef>
+        </p:style>
+        <p:txBody>
+          <a:bodyPr rtlCol="0" anchor="ctr" tIns="0" bIns="0"/>
+          <a:lstStyle/>
+          <a:p>
+            <a:pPr algn="ctr"/>
+            <a:r>
+              <a:rPr sz="1050" b="1">
+                <a:solidFill>
+                  <a:srgbClr val="D8D6F5"/>
+                </a:solidFill>
+                <a:latin typeface="Segoe UI"/>
+              </a:rPr>
+              <a:t>Team Member</a:t>
+            </a:r>
+          </a:p>
+        </p:txBody>
+      </p:sp>
     </p:spTree>
   </p:cSld>
   <p:clrMapOvr>
@@ -3608,8 +3962,8 @@
         </p:nvSpPr>
         <p:spPr>
           <a:xfrm>
-            <a:off x="10241280" y="6400800"/>
-            <a:ext cx="1645920" cy="274320"/>
+            <a:off x="5669280" y="6400800"/>
+            <a:ext cx="6217920" cy="274320"/>
           </a:xfrm>
           <a:prstGeom prst="rect">
             <a:avLst/>
@@ -3634,7 +3988,7 @@
                 </a:solidFill>
                 <a:latin typeface="Segoe UI"/>
               </a:rPr>
-              <a:t>ResearchAI  ·  2/8</a:t>
+              <a:t>ResearchAI  ·  Keshav Tomar, Astik Sharma, Shudhanshu Kumar  ·  2/9</a:t>
             </a:r>
           </a:p>
         </p:txBody>
@@ -4240,8 +4594,8 @@
         </p:nvSpPr>
         <p:spPr>
           <a:xfrm>
-            <a:off x="10241280" y="6400800"/>
-            <a:ext cx="1645920" cy="274320"/>
+            <a:off x="5669280" y="6400800"/>
+            <a:ext cx="6217920" cy="274320"/>
           </a:xfrm>
           <a:prstGeom prst="rect">
             <a:avLst/>
@@ -4266,7 +4620,7 @@
                 </a:solidFill>
                 <a:latin typeface="Segoe UI"/>
               </a:rPr>
-              <a:t>ResearchAI  ·  3/8</a:t>
+              <a:t>ResearchAI  ·  Keshav Tomar, Astik Sharma, Shudhanshu Kumar  ·  3/9</a:t>
             </a:r>
           </a:p>
         </p:txBody>
@@ -5544,8 +5898,8 @@
         </p:nvSpPr>
         <p:spPr>
           <a:xfrm>
-            <a:off x="10241280" y="6400800"/>
-            <a:ext cx="1645920" cy="274320"/>
+            <a:off x="5669280" y="6400800"/>
+            <a:ext cx="6217920" cy="274320"/>
           </a:xfrm>
           <a:prstGeom prst="rect">
             <a:avLst/>
@@ -5570,7 +5924,7 @@
                 </a:solidFill>
                 <a:latin typeface="Segoe UI"/>
               </a:rPr>
-              <a:t>ResearchAI  ·  4/8</a:t>
+              <a:t>ResearchAI  ·  Keshav Tomar, Astik Sharma, Shudhanshu Kumar  ·  4/9</a:t>
             </a:r>
           </a:p>
         </p:txBody>
@@ -5629,8 +5983,8 @@
         </p:nvSpPr>
         <p:spPr>
           <a:xfrm>
-            <a:off x="777240" y="1691640"/>
-            <a:ext cx="4846320" cy="4389120"/>
+            <a:off x="777240" y="1600200"/>
+            <a:ext cx="4846320" cy="4572000"/>
           </a:xfrm>
           <a:prstGeom prst="rect">
             <a:avLst/>
@@ -5649,7 +6003,7 @@
               </a:spcAft>
             </a:pPr>
             <a:r>
-              <a:rPr sz="1150" b="0">
+              <a:rPr sz="1050" b="0">
                 <a:solidFill>
                   <a:srgbClr val="E4E6F5"/>
                 </a:solidFill>
@@ -5663,8 +6017,11 @@
 │     ├─ dto/         request/response + validation
 │     ├─ service/     AI providers, rate limit
 │     ├─ ml/          CSV, regression, metrics
-│     ├─ repository/  database access
-│     ├─ model/       JPA entities (tables)
+│     ├─ repository/  JPA database access
+│     ├─ dao/         plain JDBC database access
+│     ├─ model/       entities (tables)
+│     ├─ exception/   custom exception classes
+│     ├─ web/         ExportServlet (HttpServlet)
 │     └─ config/      CORS, security, errors
 ├─ database/schema.sql
 ├─ scripts/  · docs/
@@ -6160,7 +6517,7 @@
                 </a:solidFill>
                 <a:latin typeface="Segoe UI"/>
               </a:rPr>
-              <a:t>Repository</a:t>
+              <a:t>Repository / DAO</a:t>
             </a:r>
           </a:p>
         </p:txBody>
@@ -6199,7 +6556,7 @@
                 </a:solidFill>
                 <a:latin typeface="Segoe UI"/>
               </a:rPr>
-              <a:t>Spring Data JPA queries</a:t>
+              <a:t>JPA queries or plain JDBC SQL</a:t>
             </a:r>
           </a:p>
         </p:txBody>
@@ -6440,7 +6797,7 @@
                 </a:solidFill>
                 <a:latin typeface="Segoe UI"/>
               </a:rPr>
-              <a:t>MYSQL SCHEMA (3 TABLES)</a:t>
+              <a:t>MYSQL SCHEMA (4 TABLES)</a:t>
             </a:r>
           </a:p>
         </p:txBody>
@@ -6492,8 +6849,8 @@
         </p:nvSpPr>
         <p:spPr>
           <a:xfrm>
-            <a:off x="10241280" y="6400800"/>
-            <a:ext cx="1645920" cy="274320"/>
+            <a:off x="5669280" y="6400800"/>
+            <a:ext cx="6217920" cy="274320"/>
           </a:xfrm>
           <a:prstGeom prst="rect">
             <a:avLst/>
@@ -6518,7 +6875,7 @@
                 </a:solidFill>
                 <a:latin typeface="Segoe UI"/>
               </a:rPr>
-              <a:t>ResearchAI  ·  5/8</a:t>
+              <a:t>ResearchAI  ·  Keshav Tomar, Astik Sharma, Shudhanshu Kumar  ·  5/9</a:t>
             </a:r>
           </a:p>
         </p:txBody>
@@ -7389,14 +7746,235 @@
       </p:sp>
       <p:sp>
         <p:nvSpPr>
-          <p:cNvPr id="14" name="TextBox 13"/>
+          <p:cNvPr id="14" name="Rectangle 13"/>
+          <p:cNvSpPr/>
+          <p:nvPr/>
+        </p:nvSpPr>
+        <p:spPr>
+          <a:xfrm>
+            <a:off x="548640" y="3429000"/>
+            <a:ext cx="3383280" cy="457200"/>
+          </a:xfrm>
+          <a:prstGeom prst="rect">
+            <a:avLst/>
+          </a:prstGeom>
+          <a:solidFill>
+            <a:srgbClr val="161A3A"/>
+          </a:solidFill>
+          <a:ln>
+            <a:noFill/>
+          </a:ln>
+          <a:effectLst/>
+        </p:spPr>
+        <p:style>
+          <a:lnRef idx="1">
+            <a:schemeClr val="accent1"/>
+          </a:lnRef>
+          <a:fillRef idx="3">
+            <a:schemeClr val="accent1"/>
+          </a:fillRef>
+          <a:effectRef idx="2">
+            <a:schemeClr val="accent1"/>
+          </a:effectRef>
+          <a:fontRef idx="minor">
+            <a:schemeClr val="lt1"/>
+          </a:fontRef>
+        </p:style>
+        <p:txBody>
+          <a:bodyPr rtlCol="0" anchor="ctr"/>
+          <a:lstStyle/>
+          <a:p>
+            <a:r>
+              <a:rPr sz="1400" b="1">
+                <a:solidFill>
+                  <a:srgbClr val="FFFFFF"/>
+                </a:solidFill>
+                <a:latin typeface="Segoe UI"/>
+              </a:rPr>
+              <a:t>experiment  (plain JDBC)</a:t>
+            </a:r>
+          </a:p>
+        </p:txBody>
+      </p:sp>
+      <p:sp>
+        <p:nvSpPr>
+          <p:cNvPr id="15" name="Rectangle 14"/>
+          <p:cNvSpPr/>
+          <p:nvPr/>
+        </p:nvSpPr>
+        <p:spPr>
+          <a:xfrm>
+            <a:off x="548640" y="3886200"/>
+            <a:ext cx="3383280" cy="1382572"/>
+          </a:xfrm>
+          <a:prstGeom prst="rect">
+            <a:avLst/>
+          </a:prstGeom>
+          <a:solidFill>
+            <a:srgbClr val="FFFFFF"/>
+          </a:solidFill>
+          <a:ln w="15875">
+            <a:solidFill>
+              <a:srgbClr val="161A3A"/>
+            </a:solidFill>
+          </a:ln>
+          <a:effectLst/>
+        </p:spPr>
+        <p:style>
+          <a:lnRef idx="1">
+            <a:schemeClr val="accent1"/>
+          </a:lnRef>
+          <a:fillRef idx="3">
+            <a:schemeClr val="accent1"/>
+          </a:fillRef>
+          <a:effectRef idx="2">
+            <a:schemeClr val="accent1"/>
+          </a:effectRef>
+          <a:fontRef idx="minor">
+            <a:schemeClr val="lt1"/>
+          </a:fontRef>
+        </p:style>
+        <p:txBody>
+          <a:bodyPr rtlCol="0" anchor="t"/>
+          <a:lstStyle/>
+          <a:p>
+            <a:pPr algn="l"/>
+            <a:r>
+              <a:rPr sz="1150" b="1">
+                <a:solidFill>
+                  <a:srgbClr val="20243A"/>
+                </a:solidFill>
+                <a:latin typeface="Consolas"/>
+              </a:rPr>
+              <a:t>PK id</a:t>
+            </a:r>
+            <a:r>
+              <a:rPr sz="1000">
+                <a:solidFill>
+                  <a:srgbClr val="737B91"/>
+                </a:solidFill>
+                <a:latin typeface="Consolas"/>
+              </a:rPr>
+              <a:t>  BIGINT AUTO_INCREMENT</a:t>
+            </a:r>
+          </a:p>
+          <a:p>
+            <a:pPr algn="l"/>
+            <a:r>
+              <a:rPr sz="1150" b="0">
+                <a:solidFill>
+                  <a:srgbClr val="20243A"/>
+                </a:solidFill>
+                <a:latin typeface="Consolas"/>
+              </a:rPr>
+              <a:t>   name</a:t>
+            </a:r>
+            <a:r>
+              <a:rPr sz="1000">
+                <a:solidFill>
+                  <a:srgbClr val="737B91"/>
+                </a:solidFill>
+                <a:latin typeface="Consolas"/>
+              </a:rPr>
+              <a:t>  VARCHAR NOT NULL</a:t>
+            </a:r>
+          </a:p>
+          <a:p>
+            <a:pPr algn="l"/>
+            <a:r>
+              <a:rPr sz="1150" b="0">
+                <a:solidFill>
+                  <a:srgbClr val="20243A"/>
+                </a:solidFill>
+                <a:latin typeface="Consolas"/>
+              </a:rPr>
+              <a:t>   model</a:t>
+            </a:r>
+            <a:r>
+              <a:rPr sz="1000">
+                <a:solidFill>
+                  <a:srgbClr val="737B91"/>
+                </a:solidFill>
+                <a:latin typeface="Consolas"/>
+              </a:rPr>
+              <a:t>  VARCHAR NOT NULL</a:t>
+            </a:r>
+          </a:p>
+          <a:p>
+            <a:pPr algn="l"/>
+            <a:r>
+              <a:rPr sz="1150" b="0">
+                <a:solidFill>
+                  <a:srgbClr val="20243A"/>
+                </a:solidFill>
+                <a:latin typeface="Consolas"/>
+              </a:rPr>
+              <a:t>   metric</a:t>
+            </a:r>
+            <a:r>
+              <a:rPr sz="1000">
+                <a:solidFill>
+                  <a:srgbClr val="737B91"/>
+                </a:solidFill>
+                <a:latin typeface="Consolas"/>
+              </a:rPr>
+              <a:t>  VARCHAR</a:t>
+            </a:r>
+          </a:p>
+          <a:p>
+            <a:pPr algn="l"/>
+            <a:r>
+              <a:rPr sz="1150" b="0">
+                <a:solidFill>
+                  <a:srgbClr val="20243A"/>
+                </a:solidFill>
+                <a:latin typeface="Consolas"/>
+              </a:rPr>
+              <a:t>   status</a:t>
+            </a:r>
+            <a:r>
+              <a:rPr sz="1000">
+                <a:solidFill>
+                  <a:srgbClr val="737B91"/>
+                </a:solidFill>
+                <a:latin typeface="Consolas"/>
+              </a:rPr>
+              <a:t>  VARCHAR</a:t>
+            </a:r>
+          </a:p>
+          <a:p>
+            <a:pPr algn="l"/>
+            <a:r>
+              <a:rPr sz="1150" b="0">
+                <a:solidFill>
+                  <a:srgbClr val="20243A"/>
+                </a:solidFill>
+                <a:latin typeface="Consolas"/>
+              </a:rPr>
+              <a:t>   created_at</a:t>
+            </a:r>
+            <a:r>
+              <a:rPr sz="1000">
+                <a:solidFill>
+                  <a:srgbClr val="737B91"/>
+                </a:solidFill>
+                <a:latin typeface="Consolas"/>
+              </a:rPr>
+              <a:t>  DATETIME</a:t>
+            </a:r>
+          </a:p>
+        </p:txBody>
+      </p:sp>
+      <p:sp>
+        <p:nvSpPr>
+          <p:cNvPr id="16" name="TextBox 15"/>
           <p:cNvSpPr txBox="1"/>
           <p:nvPr/>
         </p:nvSpPr>
         <p:spPr>
           <a:xfrm>
-            <a:off x="548640" y="3657600"/>
-            <a:ext cx="3749039" cy="2743200"/>
+            <a:off x="4389120" y="4617720"/>
+            <a:ext cx="7315200" cy="1828800"/>
           </a:xfrm>
           <a:prstGeom prst="rect">
             <a:avLst/>
@@ -7411,36 +7989,36 @@
           <a:p>
             <a:pPr>
               <a:spcAft>
-                <a:spcPts val="500"/>
+                <a:spcPts val="200"/>
               </a:spcAft>
             </a:pPr>
             <a:r>
-              <a:rPr sz="1300" b="1">
+              <a:rPr sz="1200" b="1">
                 <a:solidFill>
                   <a:srgbClr val="20243A"/>
                 </a:solidFill>
                 <a:latin typeface="Segoe UI"/>
               </a:rPr>
-              <a:t>•  Entities → tables</a:t>
-            </a:r>
-            <a:r>
-              <a:rPr sz="1300">
+              <a:t>•  3 tables via JPA/Hibernate, 1 via plain JDBC</a:t>
+            </a:r>
+            <a:r>
+              <a:rPr sz="1200">
                 <a:solidFill>
                   <a:srgbClr val="737B91"/>
                 </a:solidFill>
                 <a:latin typeface="Segoe UI"/>
               </a:rPr>
-              <a:t> via JPA/Hibernate</a:t>
+              <a:t> (same MySQL database)</a:t>
             </a:r>
           </a:p>
           <a:p>
             <a:pPr>
               <a:spcAft>
-                <a:spcPts val="500"/>
+                <a:spcPts val="200"/>
               </a:spcAft>
             </a:pPr>
             <a:r>
-              <a:rPr sz="1300" b="1">
+              <a:rPr sz="1200" b="1">
                 <a:solidFill>
                   <a:srgbClr val="20243A"/>
                 </a:solidFill>
@@ -7449,7 +8027,7 @@
               <a:t>•  Validation</a:t>
             </a:r>
             <a:r>
-              <a:rPr sz="1300">
+              <a:rPr sz="1200">
                 <a:solidFill>
                   <a:srgbClr val="737B91"/>
                 </a:solidFill>
@@ -7461,11 +8039,11 @@
           <a:p>
             <a:pPr>
               <a:spcAft>
-                <a:spcPts val="500"/>
+                <a:spcPts val="200"/>
               </a:spcAft>
             </a:pPr>
             <a:r>
-              <a:rPr sz="1300" b="1">
+              <a:rPr sz="1200" b="1">
                 <a:solidFill>
                   <a:srgbClr val="20243A"/>
                 </a:solidFill>
@@ -7474,7 +8052,7 @@
               <a:t>•  Results stored</a:t>
             </a:r>
             <a:r>
-              <a:rPr sz="1300">
+              <a:rPr sz="1200">
                 <a:solidFill>
                   <a:srgbClr val="737B91"/>
                 </a:solidFill>
@@ -7486,11 +8064,11 @@
           <a:p>
             <a:pPr>
               <a:spcAft>
-                <a:spcPts val="500"/>
+                <a:spcPts val="200"/>
               </a:spcAft>
             </a:pPr>
             <a:r>
-              <a:rPr sz="1300" b="1">
+              <a:rPr sz="1200" b="1">
                 <a:solidFill>
                   <a:srgbClr val="20243A"/>
                 </a:solidFill>
@@ -7499,23 +8077,23 @@
               <a:t>•  Link</a:t>
             </a:r>
             <a:r>
-              <a:rPr sz="1300">
+              <a:rPr sz="1200">
                 <a:solidFill>
                   <a:srgbClr val="737B91"/>
                 </a:solidFill>
                 <a:latin typeface="Segoe UI"/>
               </a:rPr>
-              <a:t> training_job.dataset_id → dataset.id (logical key: runs keep their results if a dataset is deleted)</a:t>
+              <a:t> training_job.dataset_id → dataset.id (logical key: runs keep results if a dataset is deleted)</a:t>
             </a:r>
           </a:p>
           <a:p>
             <a:pPr>
               <a:spcAft>
-                <a:spcPts val="500"/>
+                <a:spcPts val="200"/>
               </a:spcAft>
             </a:pPr>
             <a:r>
-              <a:rPr sz="1300" b="1">
+              <a:rPr sz="1200" b="1">
                 <a:solidFill>
                   <a:srgbClr val="20243A"/>
                 </a:solidFill>
@@ -7524,7 +8102,7 @@
               <a:t>•  Script</a:t>
             </a:r>
             <a:r>
-              <a:rPr sz="1300">
+              <a:rPr sz="1200">
                 <a:solidFill>
                   <a:srgbClr val="737B91"/>
                 </a:solidFill>
@@ -7691,8 +8269,8 @@
         </p:nvSpPr>
         <p:spPr>
           <a:xfrm>
-            <a:off x="10241280" y="6400800"/>
-            <a:ext cx="1645920" cy="274320"/>
+            <a:off x="5669280" y="6400800"/>
+            <a:ext cx="6217920" cy="274320"/>
           </a:xfrm>
           <a:prstGeom prst="rect">
             <a:avLst/>
@@ -7717,7 +8295,7 @@
                 </a:solidFill>
                 <a:latin typeface="Segoe UI"/>
               </a:rPr>
-              <a:t>ResearchAI  ·  6/8</a:t>
+              <a:t>ResearchAI  ·  Keshav Tomar, Astik Sharma, Shudhanshu Kumar  ·  6/9</a:t>
             </a:r>
           </a:p>
         </p:txBody>
@@ -8569,8 +9147,8 @@
         </p:nvSpPr>
         <p:spPr>
           <a:xfrm>
-            <a:off x="6629400" y="3931920"/>
-            <a:ext cx="4846320" cy="1188720"/>
+            <a:off x="6629400" y="3886200"/>
+            <a:ext cx="4846320" cy="548640"/>
           </a:xfrm>
           <a:prstGeom prst="rect">
             <a:avLst/>
@@ -8589,16 +9167,13 @@
               </a:spcAft>
             </a:pPr>
             <a:r>
-              <a:rPr sz="1250" b="0">
+              <a:rPr sz="1200" b="0">
                 <a:solidFill>
                   <a:srgbClr val="20B99A"/>
                 </a:solidFill>
                 <a:latin typeface="Consolas"/>
               </a:rPr>
-              <a:t>GET /api/health
-{"status":"UP",
- "database":"UP",
- "ai":"UP"}</a:t>
+              <a:t>GET /api/health → "database":"UP", "ai":"UP"</a:t>
             </a:r>
           </a:p>
         </p:txBody>
@@ -8611,8 +9186,8 @@
         </p:nvSpPr>
         <p:spPr>
           <a:xfrm>
-            <a:off x="6629400" y="5166360"/>
-            <a:ext cx="4846320" cy="1097280"/>
+            <a:off x="6629400" y="4480560"/>
+            <a:ext cx="4846320" cy="1645920"/>
           </a:xfrm>
           <a:prstGeom prst="rect">
             <a:avLst/>
@@ -8624,6 +9199,31 @@
             <a:spAutoFit/>
           </a:bodyPr>
           <a:lstStyle/>
+          <a:p>
+            <a:pPr>
+              <a:spcAft>
+                <a:spcPts val="400"/>
+              </a:spcAft>
+            </a:pPr>
+            <a:r>
+              <a:rPr sz="1200" b="1">
+                <a:solidFill>
+                  <a:srgbClr val="20243A"/>
+                </a:solidFill>
+                <a:latin typeface="Segoe UI"/>
+              </a:rPr>
+              <a:t>•  Two styles</a:t>
+            </a:r>
+            <a:r>
+              <a:rPr sz="1200">
+                <a:solidFill>
+                  <a:srgbClr val="737B91"/>
+                </a:solidFill>
+                <a:latin typeface="Segoe UI"/>
+              </a:rPr>
+              <a:t> JPA repositories + plain JDBC DAO (PreparedStatement, transactions)</a:t>
+            </a:r>
+          </a:p>
           <a:p>
             <a:pPr>
               <a:spcAft>
@@ -8780,7 +9380,7 @@
                 </a:solidFill>
                 <a:latin typeface="Segoe UI"/>
               </a:rPr>
-              <a:t>AESTHETICS AND USABILITY</a:t>
+              <a:t>WHERE EACH CONCEPT IS IMPLEMENTED</a:t>
             </a:r>
           </a:p>
         </p:txBody>
@@ -8819,7 +9419,7 @@
                 </a:solidFill>
                 <a:latin typeface="Segoe UI"/>
               </a:rPr>
-              <a:t>UI design &amp; responsiveness</a:t>
+              <a:t>Core Java concepts in the code</a:t>
             </a:r>
           </a:p>
         </p:txBody>
@@ -8832,8 +9432,8 @@
         </p:nvSpPr>
         <p:spPr>
           <a:xfrm>
-            <a:off x="10241280" y="6400800"/>
-            <a:ext cx="1645920" cy="274320"/>
+            <a:off x="5669280" y="6400800"/>
+            <a:ext cx="6217920" cy="274320"/>
           </a:xfrm>
           <a:prstGeom prst="rect">
             <a:avLst/>
@@ -8858,40 +9458,68 @@
                 </a:solidFill>
                 <a:latin typeface="Segoe UI"/>
               </a:rPr>
-              <a:t>ResearchAI  ·  7/8</a:t>
-            </a:r>
-          </a:p>
-        </p:txBody>
-      </p:sp>
-      <p:pic>
-        <p:nvPicPr>
-          <p:cNvPr id="6" name="Picture 5" descr="projects.png"/>
-          <p:cNvPicPr>
-            <a:picLocks noChangeAspect="1"/>
-          </p:cNvPicPr>
-          <p:nvPr/>
-        </p:nvPicPr>
-        <p:blipFill>
-          <a:blip r:embed="rId2"/>
-          <a:stretch>
-            <a:fillRect/>
-          </a:stretch>
-        </p:blipFill>
-        <p:spPr>
-          <a:xfrm>
-            <a:off x="548640" y="1417320"/>
-            <a:ext cx="5486400" cy="3429000"/>
-          </a:xfrm>
-          <a:prstGeom prst="rect">
-            <a:avLst/>
-          </a:prstGeom>
-          <a:ln w="12700">
+              <a:t>ResearchAI  ·  Keshav Tomar, Astik Sharma, Shudhanshu Kumar  ·  7/9</a:t>
+            </a:r>
+          </a:p>
+        </p:txBody>
+      </p:sp>
+      <p:sp>
+        <p:nvSpPr>
+          <p:cNvPr id="6" name="Rounded Rectangle 5"/>
+          <p:cNvSpPr/>
+          <p:nvPr/>
+        </p:nvSpPr>
+        <p:spPr>
+          <a:xfrm>
+            <a:off x="548640" y="1463040"/>
+            <a:ext cx="2651760" cy="512064"/>
+          </a:xfrm>
+          <a:prstGeom prst="roundRect">
+            <a:avLst>
+              <a:gd name="adj" fmla="val 8000"/>
+            </a:avLst>
+          </a:prstGeom>
+          <a:solidFill>
+            <a:srgbClr val="FFFFFF"/>
+          </a:solidFill>
+          <a:ln w="15875">
             <a:solidFill>
-              <a:srgbClr val="DDE0EC"/>
+              <a:srgbClr val="6257F5"/>
             </a:solidFill>
           </a:ln>
-        </p:spPr>
-      </p:pic>
+          <a:effectLst/>
+        </p:spPr>
+        <p:style>
+          <a:lnRef idx="1">
+            <a:schemeClr val="accent1"/>
+          </a:lnRef>
+          <a:fillRef idx="3">
+            <a:schemeClr val="accent1"/>
+          </a:fillRef>
+          <a:effectRef idx="2">
+            <a:schemeClr val="accent1"/>
+          </a:effectRef>
+          <a:fontRef idx="minor">
+            <a:schemeClr val="lt1"/>
+          </a:fontRef>
+        </p:style>
+        <p:txBody>
+          <a:bodyPr rtlCol="0" anchor="ctr" wrap="square" lIns="73152" rIns="73152"/>
+          <a:lstStyle/>
+          <a:p>
+            <a:pPr algn="ctr"/>
+            <a:r>
+              <a:rPr sz="1300" b="1">
+                <a:solidFill>
+                  <a:srgbClr val="6257F5"/>
+                </a:solidFill>
+                <a:latin typeface="Segoe UI"/>
+              </a:rPr>
+              <a:t>Interfaces</a:t>
+            </a:r>
+          </a:p>
+        </p:txBody>
+      </p:sp>
       <p:sp>
         <p:nvSpPr>
           <p:cNvPr id="7" name="TextBox 6"/>
@@ -8900,8 +9528,8 @@
         </p:nvSpPr>
         <p:spPr>
           <a:xfrm>
-            <a:off x="548640" y="4892040"/>
-            <a:ext cx="5486400" cy="274320"/>
+            <a:off x="3383280" y="1554480"/>
+            <a:ext cx="8321040" cy="457200"/>
           </a:xfrm>
           <a:prstGeom prst="rect">
             <a:avLst/>
@@ -8920,111 +9548,70 @@
               </a:spcAft>
             </a:pPr>
             <a:r>
-              <a:rPr sz="1000" b="0">
-                <a:solidFill>
-                  <a:srgbClr val="737B91"/>
-                </a:solidFill>
-                <a:latin typeface="Segoe UI"/>
-              </a:rPr>
-              <a:t>Desktop: Projects page (data loaded from MySQL)</a:t>
-            </a:r>
-          </a:p>
-        </p:txBody>
-      </p:sp>
-      <p:sp>
-        <p:nvSpPr>
-          <p:cNvPr id="8" name="TextBox 7"/>
-          <p:cNvSpPr txBox="1"/>
-          <p:nvPr/>
-        </p:nvSpPr>
-        <p:spPr>
-          <a:xfrm>
-            <a:off x="548640" y="5212080"/>
-            <a:ext cx="2743200" cy="1280160"/>
-          </a:xfrm>
-          <a:prstGeom prst="rect">
-            <a:avLst/>
-          </a:prstGeom>
-          <a:noFill/>
-        </p:spPr>
-        <p:txBody>
-          <a:bodyPr wrap="square">
-            <a:spAutoFit/>
-          </a:bodyPr>
-          <a:lstStyle/>
-          <a:p>
-            <a:pPr>
-              <a:spcAft>
-                <a:spcPts val="300"/>
-              </a:spcAft>
-            </a:pPr>
-            <a:r>
-              <a:rPr sz="1200" b="1">
+              <a:rPr sz="1250" b="0">
                 <a:solidFill>
                   <a:srgbClr val="20243A"/>
                 </a:solidFill>
                 <a:latin typeface="Segoe UI"/>
               </a:rPr>
-              <a:t>•  Consistent theme</a:t>
-            </a:r>
-            <a:r>
-              <a:rPr sz="1200">
-                <a:solidFill>
-                  <a:srgbClr val="737B91"/>
-                </a:solidFill>
-                <a:latin typeface="Segoe UI"/>
-              </a:rPr>
-              <a:t> purple palette, cards</a:t>
-            </a:r>
-          </a:p>
-          <a:p>
-            <a:pPr>
-              <a:spcAft>
-                <a:spcPts val="300"/>
-              </a:spcAft>
-            </a:pPr>
-            <a:r>
-              <a:rPr sz="1200" b="1">
-                <a:solidFill>
-                  <a:srgbClr val="20243A"/>
-                </a:solidFill>
-                <a:latin typeface="Segoe UI"/>
-              </a:rPr>
-              <a:t>•  Clear status</a:t>
-            </a:r>
-            <a:r>
-              <a:rPr sz="1200">
-                <a:solidFill>
-                  <a:srgbClr val="737B91"/>
-                </a:solidFill>
-                <a:latin typeface="Segoe UI"/>
-              </a:rPr>
-              <a:t> coloured tags</a:t>
-            </a:r>
-          </a:p>
-          <a:p>
-            <a:pPr>
-              <a:spcAft>
-                <a:spcPts val="300"/>
-              </a:spcAft>
-            </a:pPr>
-            <a:r>
-              <a:rPr sz="1200" b="1">
-                <a:solidFill>
-                  <a:srgbClr val="20243A"/>
-                </a:solidFill>
-                <a:latin typeface="Segoe UI"/>
-              </a:rPr>
-              <a:t>•  Feedback</a:t>
-            </a:r>
-            <a:r>
-              <a:rPr sz="1200">
-                <a:solidFill>
-                  <a:srgbClr val="737B91"/>
-                </a:solidFill>
-                <a:latin typeface="Segoe UI"/>
-              </a:rPr>
-              <a:t> loading, success/error</a:t>
+              <a:t>ChatProvider · ExperimentDao · JPA repositories</a:t>
+            </a:r>
+          </a:p>
+        </p:txBody>
+      </p:sp>
+      <p:sp>
+        <p:nvSpPr>
+          <p:cNvPr id="8" name="Rounded Rectangle 7"/>
+          <p:cNvSpPr/>
+          <p:nvPr/>
+        </p:nvSpPr>
+        <p:spPr>
+          <a:xfrm>
+            <a:off x="548640" y="2066544"/>
+            <a:ext cx="2651760" cy="512064"/>
+          </a:xfrm>
+          <a:prstGeom prst="roundRect">
+            <a:avLst>
+              <a:gd name="adj" fmla="val 8000"/>
+            </a:avLst>
+          </a:prstGeom>
+          <a:solidFill>
+            <a:srgbClr val="FFFFFF"/>
+          </a:solidFill>
+          <a:ln w="15875">
+            <a:solidFill>
+              <a:srgbClr val="6257F5"/>
+            </a:solidFill>
+          </a:ln>
+          <a:effectLst/>
+        </p:spPr>
+        <p:style>
+          <a:lnRef idx="1">
+            <a:schemeClr val="accent1"/>
+          </a:lnRef>
+          <a:fillRef idx="3">
+            <a:schemeClr val="accent1"/>
+          </a:fillRef>
+          <a:effectRef idx="2">
+            <a:schemeClr val="accent1"/>
+          </a:effectRef>
+          <a:fontRef idx="minor">
+            <a:schemeClr val="lt1"/>
+          </a:fontRef>
+        </p:style>
+        <p:txBody>
+          <a:bodyPr rtlCol="0" anchor="ctr" wrap="square" lIns="73152" rIns="73152"/>
+          <a:lstStyle/>
+          <a:p>
+            <a:pPr algn="ctr"/>
+            <a:r>
+              <a:rPr sz="1300" b="1">
+                <a:solidFill>
+                  <a:srgbClr val="6257F5"/>
+                </a:solidFill>
+                <a:latin typeface="Segoe UI"/>
+              </a:rPr>
+              <a:t>Inheritance</a:t>
             </a:r>
           </a:p>
         </p:txBody>
@@ -9037,135 +9624,8 @@
         </p:nvSpPr>
         <p:spPr>
           <a:xfrm>
-            <a:off x="3291840" y="5212080"/>
-            <a:ext cx="2834640" cy="1280160"/>
-          </a:xfrm>
-          <a:prstGeom prst="rect">
-            <a:avLst/>
-          </a:prstGeom>
-          <a:noFill/>
-        </p:spPr>
-        <p:txBody>
-          <a:bodyPr wrap="square">
-            <a:spAutoFit/>
-          </a:bodyPr>
-          <a:lstStyle/>
-          <a:p>
-            <a:pPr>
-              <a:spcAft>
-                <a:spcPts val="300"/>
-              </a:spcAft>
-            </a:pPr>
-            <a:r>
-              <a:rPr sz="1200" b="1">
-                <a:solidFill>
-                  <a:srgbClr val="20243A"/>
-                </a:solidFill>
-                <a:latin typeface="Segoe UI"/>
-              </a:rPr>
-              <a:t>•  Safe forms</a:t>
-            </a:r>
-            <a:r>
-              <a:rPr sz="1200">
-                <a:solidFill>
-                  <a:srgbClr val="737B91"/>
-                </a:solidFill>
-                <a:latin typeface="Segoe UI"/>
-              </a:rPr>
-              <a:t> Cancel never saves</a:t>
-            </a:r>
-          </a:p>
-          <a:p>
-            <a:pPr>
-              <a:spcAft>
-                <a:spcPts val="300"/>
-              </a:spcAft>
-            </a:pPr>
-            <a:r>
-              <a:rPr sz="1200" b="1">
-                <a:solidFill>
-                  <a:srgbClr val="20243A"/>
-                </a:solidFill>
-                <a:latin typeface="Segoe UI"/>
-              </a:rPr>
-              <a:t>•  Responsive</a:t>
-            </a:r>
-            <a:r>
-              <a:rPr sz="1200">
-                <a:solidFill>
-                  <a:srgbClr val="737B91"/>
-                </a:solidFill>
-                <a:latin typeface="Segoe UI"/>
-              </a:rPr>
-              <a:t> icon sidebar on phones</a:t>
-            </a:r>
-          </a:p>
-          <a:p>
-            <a:pPr>
-              <a:spcAft>
-                <a:spcPts val="300"/>
-              </a:spcAft>
-            </a:pPr>
-            <a:r>
-              <a:rPr sz="1200" b="1">
-                <a:solidFill>
-                  <a:srgbClr val="20243A"/>
-                </a:solidFill>
-                <a:latin typeface="Segoe UI"/>
-              </a:rPr>
-              <a:t>•  Accessible</a:t>
-            </a:r>
-            <a:r>
-              <a:rPr sz="1200">
-                <a:solidFill>
-                  <a:srgbClr val="737B91"/>
-                </a:solidFill>
-                <a:latin typeface="Segoe UI"/>
-              </a:rPr>
-              <a:t> labels, keyboard support</a:t>
-            </a:r>
-          </a:p>
-        </p:txBody>
-      </p:sp>
-      <p:pic>
-        <p:nvPicPr>
-          <p:cNvPr id="10" name="Picture 9" descr="mobile-overview.png"/>
-          <p:cNvPicPr>
-            <a:picLocks noChangeAspect="1"/>
-          </p:cNvPicPr>
-          <p:nvPr/>
-        </p:nvPicPr>
-        <p:blipFill>
-          <a:blip r:embed="rId3"/>
-          <a:stretch>
-            <a:fillRect/>
-          </a:stretch>
-        </p:blipFill>
-        <p:spPr>
-          <a:xfrm>
-            <a:off x="6629400" y="1417320"/>
-            <a:ext cx="2112654" cy="4572000"/>
-          </a:xfrm>
-          <a:prstGeom prst="rect">
-            <a:avLst/>
-          </a:prstGeom>
-          <a:ln w="12700">
-            <a:solidFill>
-              <a:srgbClr val="DDE0EC"/>
-            </a:solidFill>
-          </a:ln>
-        </p:spPr>
-      </p:pic>
-      <p:sp>
-        <p:nvSpPr>
-          <p:cNvPr id="11" name="TextBox 10"/>
-          <p:cNvSpPr txBox="1"/>
-          <p:nvPr/>
-        </p:nvSpPr>
-        <p:spPr>
-          <a:xfrm>
-            <a:off x="6629400" y="6035040"/>
-            <a:ext cx="2112264" cy="274320"/>
+            <a:off x="3383280" y="2157984"/>
+            <a:ext cx="8321040" cy="457200"/>
           </a:xfrm>
           <a:prstGeom prst="rect">
             <a:avLst/>
@@ -9178,62 +9638,90 @@
           </a:bodyPr>
           <a:lstStyle/>
           <a:p>
-            <a:pPr algn="ctr">
+            <a:pPr algn="l">
               <a:spcAft>
                 <a:spcPts val="400"/>
               </a:spcAft>
             </a:pPr>
             <a:r>
-              <a:rPr sz="1000" b="0">
-                <a:solidFill>
-                  <a:srgbClr val="737B91"/>
-                </a:solidFill>
-                <a:latin typeface="Segoe UI"/>
-              </a:rPr>
-              <a:t>Phone: Overview</a:t>
-            </a:r>
-          </a:p>
-        </p:txBody>
-      </p:sp>
-      <p:pic>
-        <p:nvPicPr>
-          <p:cNvPr id="12" name="Picture 11" descr="mobile-training.png"/>
-          <p:cNvPicPr>
-            <a:picLocks noChangeAspect="1"/>
-          </p:cNvPicPr>
-          <p:nvPr/>
-        </p:nvPicPr>
-        <p:blipFill>
-          <a:blip r:embed="rId4"/>
-          <a:stretch>
-            <a:fillRect/>
-          </a:stretch>
-        </p:blipFill>
-        <p:spPr>
-          <a:xfrm>
-            <a:off x="9144000" y="1417320"/>
-            <a:ext cx="2112654" cy="4572000"/>
-          </a:xfrm>
-          <a:prstGeom prst="rect">
-            <a:avLst/>
-          </a:prstGeom>
-          <a:ln w="12700">
+              <a:rPr sz="1250" b="0">
+                <a:solidFill>
+                  <a:srgbClr val="20243A"/>
+                </a:solidFill>
+                <a:latin typeface="Segoe UI"/>
+              </a:rPr>
+              <a:t>ResearchAiException → TrainingDataException, NotFoundException, DaoException · ExportServlet extends HttpServlet</a:t>
+            </a:r>
+          </a:p>
+        </p:txBody>
+      </p:sp>
+      <p:sp>
+        <p:nvSpPr>
+          <p:cNvPr id="10" name="Rounded Rectangle 9"/>
+          <p:cNvSpPr/>
+          <p:nvPr/>
+        </p:nvSpPr>
+        <p:spPr>
+          <a:xfrm>
+            <a:off x="548640" y="2670048"/>
+            <a:ext cx="2651760" cy="512064"/>
+          </a:xfrm>
+          <a:prstGeom prst="roundRect">
+            <a:avLst>
+              <a:gd name="adj" fmla="val 8000"/>
+            </a:avLst>
+          </a:prstGeom>
+          <a:solidFill>
+            <a:srgbClr val="FFFFFF"/>
+          </a:solidFill>
+          <a:ln w="15875">
             <a:solidFill>
-              <a:srgbClr val="DDE0EC"/>
+              <a:srgbClr val="6257F5"/>
             </a:solidFill>
           </a:ln>
-        </p:spPr>
-      </p:pic>
-      <p:sp>
-        <p:nvSpPr>
-          <p:cNvPr id="13" name="TextBox 12"/>
+          <a:effectLst/>
+        </p:spPr>
+        <p:style>
+          <a:lnRef idx="1">
+            <a:schemeClr val="accent1"/>
+          </a:lnRef>
+          <a:fillRef idx="3">
+            <a:schemeClr val="accent1"/>
+          </a:fillRef>
+          <a:effectRef idx="2">
+            <a:schemeClr val="accent1"/>
+          </a:effectRef>
+          <a:fontRef idx="minor">
+            <a:schemeClr val="lt1"/>
+          </a:fontRef>
+        </p:style>
+        <p:txBody>
+          <a:bodyPr rtlCol="0" anchor="ctr" wrap="square" lIns="73152" rIns="73152"/>
+          <a:lstStyle/>
+          <a:p>
+            <a:pPr algn="ctr"/>
+            <a:r>
+              <a:rPr sz="1300" b="1">
+                <a:solidFill>
+                  <a:srgbClr val="6257F5"/>
+                </a:solidFill>
+                <a:latin typeface="Segoe UI"/>
+              </a:rPr>
+              <a:t>Polymorphism</a:t>
+            </a:r>
+          </a:p>
+        </p:txBody>
+      </p:sp>
+      <p:sp>
+        <p:nvSpPr>
+          <p:cNvPr id="11" name="TextBox 10"/>
           <p:cNvSpPr txBox="1"/>
           <p:nvPr/>
         </p:nvSpPr>
         <p:spPr>
           <a:xfrm>
-            <a:off x="9144000" y="6035040"/>
-            <a:ext cx="2112264" cy="274320"/>
+            <a:off x="3383280" y="2761488"/>
+            <a:ext cx="8321040" cy="457200"/>
           </a:xfrm>
           <a:prstGeom prst="rect">
             <a:avLst/>
@@ -9246,19 +9734,538 @@
           </a:bodyPr>
           <a:lstStyle/>
           <a:p>
-            <a:pPr algn="ctr">
+            <a:pPr algn="l">
               <a:spcAft>
                 <a:spcPts val="400"/>
               </a:spcAft>
             </a:pPr>
             <a:r>
-              <a:rPr sz="1000" b="0">
+              <a:rPr sz="1250" b="0">
+                <a:solidFill>
+                  <a:srgbClr val="20243A"/>
+                </a:solidFill>
+                <a:latin typeface="Segoe UI"/>
+              </a:rPr>
+              <a:t>Ollama / Groq providers behind one interface (chosen at runtime) · each exception overrides status()</a:t>
+            </a:r>
+          </a:p>
+        </p:txBody>
+      </p:sp>
+      <p:sp>
+        <p:nvSpPr>
+          <p:cNvPr id="12" name="Rounded Rectangle 11"/>
+          <p:cNvSpPr/>
+          <p:nvPr/>
+        </p:nvSpPr>
+        <p:spPr>
+          <a:xfrm>
+            <a:off x="548640" y="3273552"/>
+            <a:ext cx="2651760" cy="512064"/>
+          </a:xfrm>
+          <a:prstGeom prst="roundRect">
+            <a:avLst>
+              <a:gd name="adj" fmla="val 8000"/>
+            </a:avLst>
+          </a:prstGeom>
+          <a:solidFill>
+            <a:srgbClr val="FFFFFF"/>
+          </a:solidFill>
+          <a:ln w="15875">
+            <a:solidFill>
+              <a:srgbClr val="6257F5"/>
+            </a:solidFill>
+          </a:ln>
+          <a:effectLst/>
+        </p:spPr>
+        <p:style>
+          <a:lnRef idx="1">
+            <a:schemeClr val="accent1"/>
+          </a:lnRef>
+          <a:fillRef idx="3">
+            <a:schemeClr val="accent1"/>
+          </a:fillRef>
+          <a:effectRef idx="2">
+            <a:schemeClr val="accent1"/>
+          </a:effectRef>
+          <a:fontRef idx="minor">
+            <a:schemeClr val="lt1"/>
+          </a:fontRef>
+        </p:style>
+        <p:txBody>
+          <a:bodyPr rtlCol="0" anchor="ctr" wrap="square" lIns="73152" rIns="73152"/>
+          <a:lstStyle/>
+          <a:p>
+            <a:pPr algn="ctr"/>
+            <a:r>
+              <a:rPr sz="1300" b="1">
+                <a:solidFill>
+                  <a:srgbClr val="6257F5"/>
+                </a:solidFill>
+                <a:latin typeface="Segoe UI"/>
+              </a:rPr>
+              <a:t>Exception handling</a:t>
+            </a:r>
+          </a:p>
+        </p:txBody>
+      </p:sp>
+      <p:sp>
+        <p:nvSpPr>
+          <p:cNvPr id="13" name="TextBox 12"/>
+          <p:cNvSpPr txBox="1"/>
+          <p:nvPr/>
+        </p:nvSpPr>
+        <p:spPr>
+          <a:xfrm>
+            <a:off x="3383280" y="3364992"/>
+            <a:ext cx="8321040" cy="457200"/>
+          </a:xfrm>
+          <a:prstGeom prst="rect">
+            <a:avLst/>
+          </a:prstGeom>
+          <a:noFill/>
+        </p:spPr>
+        <p:txBody>
+          <a:bodyPr wrap="square" anchor="t" lIns="45720" rIns="45720">
+            <a:spAutoFit/>
+          </a:bodyPr>
+          <a:lstStyle/>
+          <a:p>
+            <a:pPr algn="l">
+              <a:spcAft>
+                <a:spcPts val="400"/>
+              </a:spcAft>
+            </a:pPr>
+            <a:r>
+              <a:rPr sz="1250" b="0">
+                <a:solidFill>
+                  <a:srgbClr val="20243A"/>
+                </a:solidFill>
+                <a:latin typeface="Segoe UI"/>
+              </a:rPr>
+              <a:t>Custom hierarchy · GlobalExceptionHandler (clean JSON errors) · try-with-resources</a:t>
+            </a:r>
+          </a:p>
+        </p:txBody>
+      </p:sp>
+      <p:sp>
+        <p:nvSpPr>
+          <p:cNvPr id="14" name="Rounded Rectangle 13"/>
+          <p:cNvSpPr/>
+          <p:nvPr/>
+        </p:nvSpPr>
+        <p:spPr>
+          <a:xfrm>
+            <a:off x="548640" y="3877056"/>
+            <a:ext cx="2651760" cy="512064"/>
+          </a:xfrm>
+          <a:prstGeom prst="roundRect">
+            <a:avLst>
+              <a:gd name="adj" fmla="val 8000"/>
+            </a:avLst>
+          </a:prstGeom>
+          <a:solidFill>
+            <a:srgbClr val="FFFFFF"/>
+          </a:solidFill>
+          <a:ln w="15875">
+            <a:solidFill>
+              <a:srgbClr val="20B99A"/>
+            </a:solidFill>
+          </a:ln>
+          <a:effectLst/>
+        </p:spPr>
+        <p:style>
+          <a:lnRef idx="1">
+            <a:schemeClr val="accent1"/>
+          </a:lnRef>
+          <a:fillRef idx="3">
+            <a:schemeClr val="accent1"/>
+          </a:fillRef>
+          <a:effectRef idx="2">
+            <a:schemeClr val="accent1"/>
+          </a:effectRef>
+          <a:fontRef idx="minor">
+            <a:schemeClr val="lt1"/>
+          </a:fontRef>
+        </p:style>
+        <p:txBody>
+          <a:bodyPr rtlCol="0" anchor="ctr" wrap="square" lIns="73152" rIns="73152"/>
+          <a:lstStyle/>
+          <a:p>
+            <a:pPr algn="ctr"/>
+            <a:r>
+              <a:rPr sz="1300" b="1">
+                <a:solidFill>
+                  <a:srgbClr val="20B99A"/>
+                </a:solidFill>
+                <a:latin typeface="Segoe UI"/>
+              </a:rPr>
+              <a:t>Collections &amp; generics</a:t>
+            </a:r>
+          </a:p>
+        </p:txBody>
+      </p:sp>
+      <p:sp>
+        <p:nvSpPr>
+          <p:cNvPr id="15" name="TextBox 14"/>
+          <p:cNvSpPr txBox="1"/>
+          <p:nvPr/>
+        </p:nvSpPr>
+        <p:spPr>
+          <a:xfrm>
+            <a:off x="3383280" y="3968496"/>
+            <a:ext cx="8321040" cy="457200"/>
+          </a:xfrm>
+          <a:prstGeom prst="rect">
+            <a:avLst/>
+          </a:prstGeom>
+          <a:noFill/>
+        </p:spPr>
+        <p:txBody>
+          <a:bodyPr wrap="square" anchor="t" lIns="45720" rIns="45720">
+            <a:spAutoFit/>
+          </a:bodyPr>
+          <a:lstStyle/>
+          <a:p>
+            <a:pPr algn="l">
+              <a:spcAft>
+                <a:spcPts val="400"/>
+              </a:spcAft>
+            </a:pPr>
+            <a:r>
+              <a:rPr sz="1250" b="0">
+                <a:solidFill>
+                  <a:srgbClr val="20243A"/>
+                </a:solidFill>
+                <a:latin typeface="Segoe UI"/>
+              </a:rPr>
+              <a:t>List, Map, Set, Deque, Optional · ConcurrentHashMap · JpaRepository&lt;T, ID&gt;</a:t>
+            </a:r>
+          </a:p>
+        </p:txBody>
+      </p:sp>
+      <p:sp>
+        <p:nvSpPr>
+          <p:cNvPr id="16" name="Rounded Rectangle 15"/>
+          <p:cNvSpPr/>
+          <p:nvPr/>
+        </p:nvSpPr>
+        <p:spPr>
+          <a:xfrm>
+            <a:off x="548640" y="4480560"/>
+            <a:ext cx="2651760" cy="512064"/>
+          </a:xfrm>
+          <a:prstGeom prst="roundRect">
+            <a:avLst>
+              <a:gd name="adj" fmla="val 8000"/>
+            </a:avLst>
+          </a:prstGeom>
+          <a:solidFill>
+            <a:srgbClr val="FFFFFF"/>
+          </a:solidFill>
+          <a:ln w="15875">
+            <a:solidFill>
+              <a:srgbClr val="20B99A"/>
+            </a:solidFill>
+          </a:ln>
+          <a:effectLst/>
+        </p:spPr>
+        <p:style>
+          <a:lnRef idx="1">
+            <a:schemeClr val="accent1"/>
+          </a:lnRef>
+          <a:fillRef idx="3">
+            <a:schemeClr val="accent1"/>
+          </a:fillRef>
+          <a:effectRef idx="2">
+            <a:schemeClr val="accent1"/>
+          </a:effectRef>
+          <a:fontRef idx="minor">
+            <a:schemeClr val="lt1"/>
+          </a:fontRef>
+        </p:style>
+        <p:txBody>
+          <a:bodyPr rtlCol="0" anchor="ctr" wrap="square" lIns="73152" rIns="73152"/>
+          <a:lstStyle/>
+          <a:p>
+            <a:pPr algn="ctr"/>
+            <a:r>
+              <a:rPr sz="1300" b="1">
+                <a:solidFill>
+                  <a:srgbClr val="20B99A"/>
+                </a:solidFill>
+                <a:latin typeface="Segoe UI"/>
+              </a:rPr>
+              <a:t>Multithreading</a:t>
+            </a:r>
+          </a:p>
+        </p:txBody>
+      </p:sp>
+      <p:sp>
+        <p:nvSpPr>
+          <p:cNvPr id="17" name="TextBox 16"/>
+          <p:cNvSpPr txBox="1"/>
+          <p:nvPr/>
+        </p:nvSpPr>
+        <p:spPr>
+          <a:xfrm>
+            <a:off x="3383280" y="4572000"/>
+            <a:ext cx="8321040" cy="457200"/>
+          </a:xfrm>
+          <a:prstGeom prst="rect">
+            <a:avLst/>
+          </a:prstGeom>
+          <a:noFill/>
+        </p:spPr>
+        <p:txBody>
+          <a:bodyPr wrap="square" anchor="t" lIns="45720" rIns="45720">
+            <a:spAutoFit/>
+          </a:bodyPr>
+          <a:lstStyle/>
+          <a:p>
+            <a:pPr algn="l">
+              <a:spcAft>
+                <a:spcPts val="400"/>
+              </a:spcAft>
+            </a:pPr>
+            <a:r>
+              <a:rPr sz="1250" b="0">
+                <a:solidFill>
+                  <a:srgbClr val="20243A"/>
+                </a:solidFill>
+                <a:latin typeface="Segoe UI"/>
+              </a:rPr>
+              <a:t>ThreadPoolExecutor runs training jobs · synchronized rate limiter · volatile cache</a:t>
+            </a:r>
+          </a:p>
+        </p:txBody>
+      </p:sp>
+      <p:sp>
+        <p:nvSpPr>
+          <p:cNvPr id="18" name="Rounded Rectangle 17"/>
+          <p:cNvSpPr/>
+          <p:nvPr/>
+        </p:nvSpPr>
+        <p:spPr>
+          <a:xfrm>
+            <a:off x="548640" y="5084064"/>
+            <a:ext cx="2651760" cy="512064"/>
+          </a:xfrm>
+          <a:prstGeom prst="roundRect">
+            <a:avLst>
+              <a:gd name="adj" fmla="val 8000"/>
+            </a:avLst>
+          </a:prstGeom>
+          <a:solidFill>
+            <a:srgbClr val="FFFFFF"/>
+          </a:solidFill>
+          <a:ln w="15875">
+            <a:solidFill>
+              <a:srgbClr val="E69A2E"/>
+            </a:solidFill>
+          </a:ln>
+          <a:effectLst/>
+        </p:spPr>
+        <p:style>
+          <a:lnRef idx="1">
+            <a:schemeClr val="accent1"/>
+          </a:lnRef>
+          <a:fillRef idx="3">
+            <a:schemeClr val="accent1"/>
+          </a:fillRef>
+          <a:effectRef idx="2">
+            <a:schemeClr val="accent1"/>
+          </a:effectRef>
+          <a:fontRef idx="minor">
+            <a:schemeClr val="lt1"/>
+          </a:fontRef>
+        </p:style>
+        <p:txBody>
+          <a:bodyPr rtlCol="0" anchor="ctr" wrap="square" lIns="73152" rIns="73152"/>
+          <a:lstStyle/>
+          <a:p>
+            <a:pPr algn="ctr"/>
+            <a:r>
+              <a:rPr sz="1300" b="1">
+                <a:solidFill>
+                  <a:srgbClr val="E69A2E"/>
+                </a:solidFill>
+                <a:latin typeface="Segoe UI"/>
+              </a:rPr>
+              <a:t>JDBC</a:t>
+            </a:r>
+          </a:p>
+        </p:txBody>
+      </p:sp>
+      <p:sp>
+        <p:nvSpPr>
+          <p:cNvPr id="19" name="TextBox 18"/>
+          <p:cNvSpPr txBox="1"/>
+          <p:nvPr/>
+        </p:nvSpPr>
+        <p:spPr>
+          <a:xfrm>
+            <a:off x="3383280" y="5175504"/>
+            <a:ext cx="8321040" cy="457200"/>
+          </a:xfrm>
+          <a:prstGeom prst="rect">
+            <a:avLst/>
+          </a:prstGeom>
+          <a:noFill/>
+        </p:spPr>
+        <p:txBody>
+          <a:bodyPr wrap="square" anchor="t" lIns="45720" rIns="45720">
+            <a:spAutoFit/>
+          </a:bodyPr>
+          <a:lstStyle/>
+          <a:p>
+            <a:pPr algn="l">
+              <a:spcAft>
+                <a:spcPts val="400"/>
+              </a:spcAft>
+            </a:pPr>
+            <a:r>
+              <a:rPr sz="1250" b="0">
+                <a:solidFill>
+                  <a:srgbClr val="20243A"/>
+                </a:solidFill>
+                <a:latin typeface="Segoe UI"/>
+              </a:rPr>
+              <a:t>JdbcExperimentDao: Connection → PreparedStatement → ResultSet · generated keys · commit / rollback</a:t>
+            </a:r>
+          </a:p>
+        </p:txBody>
+      </p:sp>
+      <p:sp>
+        <p:nvSpPr>
+          <p:cNvPr id="20" name="Rounded Rectangle 19"/>
+          <p:cNvSpPr/>
+          <p:nvPr/>
+        </p:nvSpPr>
+        <p:spPr>
+          <a:xfrm>
+            <a:off x="548640" y="5687568"/>
+            <a:ext cx="2651760" cy="512064"/>
+          </a:xfrm>
+          <a:prstGeom prst="roundRect">
+            <a:avLst>
+              <a:gd name="adj" fmla="val 8000"/>
+            </a:avLst>
+          </a:prstGeom>
+          <a:solidFill>
+            <a:srgbClr val="FFFFFF"/>
+          </a:solidFill>
+          <a:ln w="15875">
+            <a:solidFill>
+              <a:srgbClr val="E69A2E"/>
+            </a:solidFill>
+          </a:ln>
+          <a:effectLst/>
+        </p:spPr>
+        <p:style>
+          <a:lnRef idx="1">
+            <a:schemeClr val="accent1"/>
+          </a:lnRef>
+          <a:fillRef idx="3">
+            <a:schemeClr val="accent1"/>
+          </a:fillRef>
+          <a:effectRef idx="2">
+            <a:schemeClr val="accent1"/>
+          </a:effectRef>
+          <a:fontRef idx="minor">
+            <a:schemeClr val="lt1"/>
+          </a:fontRef>
+        </p:style>
+        <p:txBody>
+          <a:bodyPr rtlCol="0" anchor="ctr" wrap="square" lIns="73152" rIns="73152"/>
+          <a:lstStyle/>
+          <a:p>
+            <a:pPr algn="ctr"/>
+            <a:r>
+              <a:rPr sz="1300" b="1">
+                <a:solidFill>
+                  <a:srgbClr val="E69A2E"/>
+                </a:solidFill>
+                <a:latin typeface="Segoe UI"/>
+              </a:rPr>
+              <a:t>Servlets &amp; web</a:t>
+            </a:r>
+          </a:p>
+        </p:txBody>
+      </p:sp>
+      <p:sp>
+        <p:nvSpPr>
+          <p:cNvPr id="21" name="TextBox 20"/>
+          <p:cNvSpPr txBox="1"/>
+          <p:nvPr/>
+        </p:nvSpPr>
+        <p:spPr>
+          <a:xfrm>
+            <a:off x="3383280" y="5779008"/>
+            <a:ext cx="8321040" cy="457200"/>
+          </a:xfrm>
+          <a:prstGeom prst="rect">
+            <a:avLst/>
+          </a:prstGeom>
+          <a:noFill/>
+        </p:spPr>
+        <p:txBody>
+          <a:bodyPr wrap="square" anchor="t" lIns="45720" rIns="45720">
+            <a:spAutoFit/>
+          </a:bodyPr>
+          <a:lstStyle/>
+          <a:p>
+            <a:pPr algn="l">
+              <a:spcAft>
+                <a:spcPts val="400"/>
+              </a:spcAft>
+            </a:pPr>
+            <a:r>
+              <a:rPr sz="1250" b="0">
+                <a:solidFill>
+                  <a:srgbClr val="20243A"/>
+                </a:solidFill>
+                <a:latin typeface="Segoe UI"/>
+              </a:rPr>
+              <a:t>ExportServlet.doGet() streams CSV · AccessKeyFilter (servlet filter) · REST controllers</a:t>
+            </a:r>
+          </a:p>
+        </p:txBody>
+      </p:sp>
+      <p:sp>
+        <p:nvSpPr>
+          <p:cNvPr id="22" name="TextBox 21"/>
+          <p:cNvSpPr txBox="1"/>
+          <p:nvPr/>
+        </p:nvSpPr>
+        <p:spPr>
+          <a:xfrm>
+            <a:off x="548640" y="6355080"/>
+            <a:ext cx="10972800" cy="274320"/>
+          </a:xfrm>
+          <a:prstGeom prst="rect">
+            <a:avLst/>
+          </a:prstGeom>
+          <a:noFill/>
+        </p:spPr>
+        <p:txBody>
+          <a:bodyPr wrap="square" anchor="t" lIns="45720" rIns="45720">
+            <a:spAutoFit/>
+          </a:bodyPr>
+          <a:lstStyle/>
+          <a:p>
+            <a:pPr algn="l">
+              <a:spcAft>
+                <a:spcPts val="400"/>
+              </a:spcAft>
+            </a:pPr>
+            <a:r>
+              <a:rPr sz="1100" b="0">
                 <a:solidFill>
                   <a:srgbClr val="737B91"/>
                 </a:solidFill>
                 <a:latin typeface="Segoe UI"/>
               </a:rPr>
-              <a:t>Phone: Training result</a:t>
+              <a:t>Packages: controller · service · ml · dao · repository · model · exception · web · config  —  44 automated tests</a:t>
             </a:r>
           </a:p>
         </p:txBody>
@@ -9367,7 +10374,7 @@
                 </a:solidFill>
                 <a:latin typeface="Segoe UI"/>
               </a:rPr>
-              <a:t>WHERE THE PROJECT STANDS</a:t>
+              <a:t>AESTHETICS AND USABILITY</a:t>
             </a:r>
           </a:p>
         </p:txBody>
@@ -9406,7 +10413,7 @@
                 </a:solidFill>
                 <a:latin typeface="Segoe UI"/>
               </a:rPr>
-              <a:t>Progress, testing &amp; next steps</a:t>
+              <a:t>UI design &amp; responsiveness</a:t>
             </a:r>
           </a:p>
         </p:txBody>
@@ -9419,8 +10426,8 @@
         </p:nvSpPr>
         <p:spPr>
           <a:xfrm>
-            <a:off x="10241280" y="6400800"/>
-            <a:ext cx="1645920" cy="274320"/>
+            <a:off x="5669280" y="6400800"/>
+            <a:ext cx="6217920" cy="274320"/>
           </a:xfrm>
           <a:prstGeom prst="rect">
             <a:avLst/>
@@ -9445,7 +10452,594 @@
                 </a:solidFill>
                 <a:latin typeface="Segoe UI"/>
               </a:rPr>
-              <a:t>ResearchAI  ·  8/8</a:t>
+              <a:t>ResearchAI  ·  Keshav Tomar, Astik Sharma, Shudhanshu Kumar  ·  8/9</a:t>
+            </a:r>
+          </a:p>
+        </p:txBody>
+      </p:sp>
+      <p:pic>
+        <p:nvPicPr>
+          <p:cNvPr id="6" name="Picture 5" descr="projects.png"/>
+          <p:cNvPicPr>
+            <a:picLocks noChangeAspect="1"/>
+          </p:cNvPicPr>
+          <p:nvPr/>
+        </p:nvPicPr>
+        <p:blipFill>
+          <a:blip r:embed="rId2"/>
+          <a:stretch>
+            <a:fillRect/>
+          </a:stretch>
+        </p:blipFill>
+        <p:spPr>
+          <a:xfrm>
+            <a:off x="548640" y="1417320"/>
+            <a:ext cx="5486400" cy="3429000"/>
+          </a:xfrm>
+          <a:prstGeom prst="rect">
+            <a:avLst/>
+          </a:prstGeom>
+          <a:ln w="12700">
+            <a:solidFill>
+              <a:srgbClr val="DDE0EC"/>
+            </a:solidFill>
+          </a:ln>
+        </p:spPr>
+      </p:pic>
+      <p:sp>
+        <p:nvSpPr>
+          <p:cNvPr id="7" name="TextBox 6"/>
+          <p:cNvSpPr txBox="1"/>
+          <p:nvPr/>
+        </p:nvSpPr>
+        <p:spPr>
+          <a:xfrm>
+            <a:off x="548640" y="4892040"/>
+            <a:ext cx="5486400" cy="274320"/>
+          </a:xfrm>
+          <a:prstGeom prst="rect">
+            <a:avLst/>
+          </a:prstGeom>
+          <a:noFill/>
+        </p:spPr>
+        <p:txBody>
+          <a:bodyPr wrap="square" anchor="t" lIns="45720" rIns="45720">
+            <a:spAutoFit/>
+          </a:bodyPr>
+          <a:lstStyle/>
+          <a:p>
+            <a:pPr algn="l">
+              <a:spcAft>
+                <a:spcPts val="400"/>
+              </a:spcAft>
+            </a:pPr>
+            <a:r>
+              <a:rPr sz="1000" b="0">
+                <a:solidFill>
+                  <a:srgbClr val="737B91"/>
+                </a:solidFill>
+                <a:latin typeface="Segoe UI"/>
+              </a:rPr>
+              <a:t>Desktop: Projects page (data loaded from MySQL)</a:t>
+            </a:r>
+          </a:p>
+        </p:txBody>
+      </p:sp>
+      <p:sp>
+        <p:nvSpPr>
+          <p:cNvPr id="8" name="TextBox 7"/>
+          <p:cNvSpPr txBox="1"/>
+          <p:nvPr/>
+        </p:nvSpPr>
+        <p:spPr>
+          <a:xfrm>
+            <a:off x="548640" y="5212080"/>
+            <a:ext cx="2743200" cy="1280160"/>
+          </a:xfrm>
+          <a:prstGeom prst="rect">
+            <a:avLst/>
+          </a:prstGeom>
+          <a:noFill/>
+        </p:spPr>
+        <p:txBody>
+          <a:bodyPr wrap="square">
+            <a:spAutoFit/>
+          </a:bodyPr>
+          <a:lstStyle/>
+          <a:p>
+            <a:pPr>
+              <a:spcAft>
+                <a:spcPts val="300"/>
+              </a:spcAft>
+            </a:pPr>
+            <a:r>
+              <a:rPr sz="1200" b="1">
+                <a:solidFill>
+                  <a:srgbClr val="20243A"/>
+                </a:solidFill>
+                <a:latin typeface="Segoe UI"/>
+              </a:rPr>
+              <a:t>•  Consistent theme</a:t>
+            </a:r>
+            <a:r>
+              <a:rPr sz="1200">
+                <a:solidFill>
+                  <a:srgbClr val="737B91"/>
+                </a:solidFill>
+                <a:latin typeface="Segoe UI"/>
+              </a:rPr>
+              <a:t> purple palette, cards</a:t>
+            </a:r>
+          </a:p>
+          <a:p>
+            <a:pPr>
+              <a:spcAft>
+                <a:spcPts val="300"/>
+              </a:spcAft>
+            </a:pPr>
+            <a:r>
+              <a:rPr sz="1200" b="1">
+                <a:solidFill>
+                  <a:srgbClr val="20243A"/>
+                </a:solidFill>
+                <a:latin typeface="Segoe UI"/>
+              </a:rPr>
+              <a:t>•  Clear status</a:t>
+            </a:r>
+            <a:r>
+              <a:rPr sz="1200">
+                <a:solidFill>
+                  <a:srgbClr val="737B91"/>
+                </a:solidFill>
+                <a:latin typeface="Segoe UI"/>
+              </a:rPr>
+              <a:t> coloured tags</a:t>
+            </a:r>
+          </a:p>
+          <a:p>
+            <a:pPr>
+              <a:spcAft>
+                <a:spcPts val="300"/>
+              </a:spcAft>
+            </a:pPr>
+            <a:r>
+              <a:rPr sz="1200" b="1">
+                <a:solidFill>
+                  <a:srgbClr val="20243A"/>
+                </a:solidFill>
+                <a:latin typeface="Segoe UI"/>
+              </a:rPr>
+              <a:t>•  Feedback</a:t>
+            </a:r>
+            <a:r>
+              <a:rPr sz="1200">
+                <a:solidFill>
+                  <a:srgbClr val="737B91"/>
+                </a:solidFill>
+                <a:latin typeface="Segoe UI"/>
+              </a:rPr>
+              <a:t> loading, success/error</a:t>
+            </a:r>
+          </a:p>
+        </p:txBody>
+      </p:sp>
+      <p:sp>
+        <p:nvSpPr>
+          <p:cNvPr id="9" name="TextBox 8"/>
+          <p:cNvSpPr txBox="1"/>
+          <p:nvPr/>
+        </p:nvSpPr>
+        <p:spPr>
+          <a:xfrm>
+            <a:off x="3291840" y="5212080"/>
+            <a:ext cx="2834640" cy="1280160"/>
+          </a:xfrm>
+          <a:prstGeom prst="rect">
+            <a:avLst/>
+          </a:prstGeom>
+          <a:noFill/>
+        </p:spPr>
+        <p:txBody>
+          <a:bodyPr wrap="square">
+            <a:spAutoFit/>
+          </a:bodyPr>
+          <a:lstStyle/>
+          <a:p>
+            <a:pPr>
+              <a:spcAft>
+                <a:spcPts val="300"/>
+              </a:spcAft>
+            </a:pPr>
+            <a:r>
+              <a:rPr sz="1200" b="1">
+                <a:solidFill>
+                  <a:srgbClr val="20243A"/>
+                </a:solidFill>
+                <a:latin typeface="Segoe UI"/>
+              </a:rPr>
+              <a:t>•  Safe forms</a:t>
+            </a:r>
+            <a:r>
+              <a:rPr sz="1200">
+                <a:solidFill>
+                  <a:srgbClr val="737B91"/>
+                </a:solidFill>
+                <a:latin typeface="Segoe UI"/>
+              </a:rPr>
+              <a:t> Cancel never saves</a:t>
+            </a:r>
+          </a:p>
+          <a:p>
+            <a:pPr>
+              <a:spcAft>
+                <a:spcPts val="300"/>
+              </a:spcAft>
+            </a:pPr>
+            <a:r>
+              <a:rPr sz="1200" b="1">
+                <a:solidFill>
+                  <a:srgbClr val="20243A"/>
+                </a:solidFill>
+                <a:latin typeface="Segoe UI"/>
+              </a:rPr>
+              <a:t>•  Responsive</a:t>
+            </a:r>
+            <a:r>
+              <a:rPr sz="1200">
+                <a:solidFill>
+                  <a:srgbClr val="737B91"/>
+                </a:solidFill>
+                <a:latin typeface="Segoe UI"/>
+              </a:rPr>
+              <a:t> icon sidebar on phones</a:t>
+            </a:r>
+          </a:p>
+          <a:p>
+            <a:pPr>
+              <a:spcAft>
+                <a:spcPts val="300"/>
+              </a:spcAft>
+            </a:pPr>
+            <a:r>
+              <a:rPr sz="1200" b="1">
+                <a:solidFill>
+                  <a:srgbClr val="20243A"/>
+                </a:solidFill>
+                <a:latin typeface="Segoe UI"/>
+              </a:rPr>
+              <a:t>•  Accessible</a:t>
+            </a:r>
+            <a:r>
+              <a:rPr sz="1200">
+                <a:solidFill>
+                  <a:srgbClr val="737B91"/>
+                </a:solidFill>
+                <a:latin typeface="Segoe UI"/>
+              </a:rPr>
+              <a:t> labels, keyboard support</a:t>
+            </a:r>
+          </a:p>
+        </p:txBody>
+      </p:sp>
+      <p:pic>
+        <p:nvPicPr>
+          <p:cNvPr id="10" name="Picture 9" descr="mobile-overview.png"/>
+          <p:cNvPicPr>
+            <a:picLocks noChangeAspect="1"/>
+          </p:cNvPicPr>
+          <p:nvPr/>
+        </p:nvPicPr>
+        <p:blipFill>
+          <a:blip r:embed="rId3"/>
+          <a:stretch>
+            <a:fillRect/>
+          </a:stretch>
+        </p:blipFill>
+        <p:spPr>
+          <a:xfrm>
+            <a:off x="6629400" y="1417320"/>
+            <a:ext cx="2112654" cy="4572000"/>
+          </a:xfrm>
+          <a:prstGeom prst="rect">
+            <a:avLst/>
+          </a:prstGeom>
+          <a:ln w="12700">
+            <a:solidFill>
+              <a:srgbClr val="DDE0EC"/>
+            </a:solidFill>
+          </a:ln>
+        </p:spPr>
+      </p:pic>
+      <p:sp>
+        <p:nvSpPr>
+          <p:cNvPr id="11" name="TextBox 10"/>
+          <p:cNvSpPr txBox="1"/>
+          <p:nvPr/>
+        </p:nvSpPr>
+        <p:spPr>
+          <a:xfrm>
+            <a:off x="6629400" y="6035040"/>
+            <a:ext cx="2112264" cy="274320"/>
+          </a:xfrm>
+          <a:prstGeom prst="rect">
+            <a:avLst/>
+          </a:prstGeom>
+          <a:noFill/>
+        </p:spPr>
+        <p:txBody>
+          <a:bodyPr wrap="square" anchor="t" lIns="45720" rIns="45720">
+            <a:spAutoFit/>
+          </a:bodyPr>
+          <a:lstStyle/>
+          <a:p>
+            <a:pPr algn="ctr">
+              <a:spcAft>
+                <a:spcPts val="400"/>
+              </a:spcAft>
+            </a:pPr>
+            <a:r>
+              <a:rPr sz="1000" b="0">
+                <a:solidFill>
+                  <a:srgbClr val="737B91"/>
+                </a:solidFill>
+                <a:latin typeface="Segoe UI"/>
+              </a:rPr>
+              <a:t>Phone: Overview</a:t>
+            </a:r>
+          </a:p>
+        </p:txBody>
+      </p:sp>
+      <p:pic>
+        <p:nvPicPr>
+          <p:cNvPr id="12" name="Picture 11" descr="mobile-training.png"/>
+          <p:cNvPicPr>
+            <a:picLocks noChangeAspect="1"/>
+          </p:cNvPicPr>
+          <p:nvPr/>
+        </p:nvPicPr>
+        <p:blipFill>
+          <a:blip r:embed="rId4"/>
+          <a:stretch>
+            <a:fillRect/>
+          </a:stretch>
+        </p:blipFill>
+        <p:spPr>
+          <a:xfrm>
+            <a:off x="9144000" y="1417320"/>
+            <a:ext cx="2112654" cy="4572000"/>
+          </a:xfrm>
+          <a:prstGeom prst="rect">
+            <a:avLst/>
+          </a:prstGeom>
+          <a:ln w="12700">
+            <a:solidFill>
+              <a:srgbClr val="DDE0EC"/>
+            </a:solidFill>
+          </a:ln>
+        </p:spPr>
+      </p:pic>
+      <p:sp>
+        <p:nvSpPr>
+          <p:cNvPr id="13" name="TextBox 12"/>
+          <p:cNvSpPr txBox="1"/>
+          <p:nvPr/>
+        </p:nvSpPr>
+        <p:spPr>
+          <a:xfrm>
+            <a:off x="9144000" y="6035040"/>
+            <a:ext cx="2112264" cy="274320"/>
+          </a:xfrm>
+          <a:prstGeom prst="rect">
+            <a:avLst/>
+          </a:prstGeom>
+          <a:noFill/>
+        </p:spPr>
+        <p:txBody>
+          <a:bodyPr wrap="square" anchor="t" lIns="45720" rIns="45720">
+            <a:spAutoFit/>
+          </a:bodyPr>
+          <a:lstStyle/>
+          <a:p>
+            <a:pPr algn="ctr">
+              <a:spcAft>
+                <a:spcPts val="400"/>
+              </a:spcAft>
+            </a:pPr>
+            <a:r>
+              <a:rPr sz="1000" b="0">
+                <a:solidFill>
+                  <a:srgbClr val="737B91"/>
+                </a:solidFill>
+                <a:latin typeface="Segoe UI"/>
+              </a:rPr>
+              <a:t>Phone: Training result</a:t>
+            </a:r>
+          </a:p>
+        </p:txBody>
+      </p:sp>
+    </p:spTree>
+  </p:cSld>
+  <p:clrMapOvr>
+    <a:masterClrMapping/>
+  </p:clrMapOvr>
+</p:sld>
+</file>
+
+<file path=ppt/slides/slide9.xml><?xml version="1.0" encoding="utf-8"?>
+<p:sld xmlns:a="http://schemas.openxmlformats.org/drawingml/2006/main" xmlns:p="http://schemas.openxmlformats.org/presentationml/2006/main" xmlns:r="http://schemas.openxmlformats.org/officeDocument/2006/relationships">
+  <p:cSld>
+    <p:bg>
+      <p:bgPr>
+        <a:solidFill>
+          <a:srgbClr val="F7F8FC"/>
+        </a:solidFill>
+        <a:effectLst/>
+      </p:bgPr>
+    </p:bg>
+    <p:spTree>
+      <p:nvGrpSpPr>
+        <p:cNvPr id="1" name=""/>
+        <p:cNvGrpSpPr/>
+        <p:nvPr/>
+      </p:nvGrpSpPr>
+      <p:grpSpPr/>
+      <p:sp>
+        <p:nvSpPr>
+          <p:cNvPr id="2" name="Rectangle 1"/>
+          <p:cNvSpPr/>
+          <p:nvPr/>
+        </p:nvSpPr>
+        <p:spPr>
+          <a:xfrm>
+            <a:off x="0" y="0"/>
+            <a:ext cx="164592" cy="6858000"/>
+          </a:xfrm>
+          <a:prstGeom prst="rect">
+            <a:avLst/>
+          </a:prstGeom>
+          <a:solidFill>
+            <a:srgbClr val="6257F5"/>
+          </a:solidFill>
+          <a:ln>
+            <a:noFill/>
+          </a:ln>
+          <a:effectLst/>
+        </p:spPr>
+        <p:style>
+          <a:lnRef idx="1">
+            <a:schemeClr val="accent1"/>
+          </a:lnRef>
+          <a:fillRef idx="3">
+            <a:schemeClr val="accent1"/>
+          </a:fillRef>
+          <a:effectRef idx="2">
+            <a:schemeClr val="accent1"/>
+          </a:effectRef>
+          <a:fontRef idx="minor">
+            <a:schemeClr val="lt1"/>
+          </a:fontRef>
+        </p:style>
+        <p:txBody>
+          <a:bodyPr rtlCol="0" anchor="ctr"/>
+          <a:lstStyle/>
+          <a:p>
+            <a:pPr algn="ctr"/>
+          </a:p>
+        </p:txBody>
+      </p:sp>
+      <p:sp>
+        <p:nvSpPr>
+          <p:cNvPr id="3" name="TextBox 2"/>
+          <p:cNvSpPr txBox="1"/>
+          <p:nvPr/>
+        </p:nvSpPr>
+        <p:spPr>
+          <a:xfrm>
+            <a:off x="548640" y="320040"/>
+            <a:ext cx="8229600" cy="320040"/>
+          </a:xfrm>
+          <a:prstGeom prst="rect">
+            <a:avLst/>
+          </a:prstGeom>
+          <a:noFill/>
+        </p:spPr>
+        <p:txBody>
+          <a:bodyPr wrap="square" anchor="t" lIns="45720" rIns="45720">
+            <a:spAutoFit/>
+          </a:bodyPr>
+          <a:lstStyle/>
+          <a:p>
+            <a:pPr algn="l">
+              <a:spcAft>
+                <a:spcPts val="400"/>
+              </a:spcAft>
+            </a:pPr>
+            <a:r>
+              <a:rPr sz="1200" b="1">
+                <a:solidFill>
+                  <a:srgbClr val="6257F5"/>
+                </a:solidFill>
+                <a:latin typeface="Segoe UI"/>
+              </a:rPr>
+              <a:t>WHERE THE PROJECT STANDS</a:t>
+            </a:r>
+          </a:p>
+        </p:txBody>
+      </p:sp>
+      <p:sp>
+        <p:nvSpPr>
+          <p:cNvPr id="4" name="TextBox 3"/>
+          <p:cNvSpPr txBox="1"/>
+          <p:nvPr/>
+        </p:nvSpPr>
+        <p:spPr>
+          <a:xfrm>
+            <a:off x="548640" y="594360"/>
+            <a:ext cx="10515600" cy="731520"/>
+          </a:xfrm>
+          <a:prstGeom prst="rect">
+            <a:avLst/>
+          </a:prstGeom>
+          <a:noFill/>
+        </p:spPr>
+        <p:txBody>
+          <a:bodyPr wrap="square" anchor="t" lIns="45720" rIns="45720">
+            <a:spAutoFit/>
+          </a:bodyPr>
+          <a:lstStyle/>
+          <a:p>
+            <a:pPr algn="l">
+              <a:spcAft>
+                <a:spcPts val="400"/>
+              </a:spcAft>
+            </a:pPr>
+            <a:r>
+              <a:rPr sz="3000" b="1">
+                <a:solidFill>
+                  <a:srgbClr val="20243A"/>
+                </a:solidFill>
+                <a:latin typeface="Segoe UI"/>
+              </a:rPr>
+              <a:t>Progress, testing &amp; next steps</a:t>
+            </a:r>
+          </a:p>
+        </p:txBody>
+      </p:sp>
+      <p:sp>
+        <p:nvSpPr>
+          <p:cNvPr id="5" name="TextBox 4"/>
+          <p:cNvSpPr txBox="1"/>
+          <p:nvPr/>
+        </p:nvSpPr>
+        <p:spPr>
+          <a:xfrm>
+            <a:off x="5669280" y="6400800"/>
+            <a:ext cx="6217920" cy="274320"/>
+          </a:xfrm>
+          <a:prstGeom prst="rect">
+            <a:avLst/>
+          </a:prstGeom>
+          <a:noFill/>
+        </p:spPr>
+        <p:txBody>
+          <a:bodyPr wrap="square" anchor="t" lIns="45720" rIns="45720">
+            <a:spAutoFit/>
+          </a:bodyPr>
+          <a:lstStyle/>
+          <a:p>
+            <a:pPr algn="r">
+              <a:spcAft>
+                <a:spcPts val="400"/>
+              </a:spcAft>
+            </a:pPr>
+            <a:r>
+              <a:rPr sz="1000" b="0">
+                <a:solidFill>
+                  <a:srgbClr val="737B91"/>
+                </a:solidFill>
+                <a:latin typeface="Segoe UI"/>
+              </a:rPr>
+              <a:t>ResearchAI  ·  Keshav Tomar, Astik Sharma, Shudhanshu Kumar  ·  9/9</a:t>
             </a:r>
           </a:p>
         </p:txBody>
@@ -9532,7 +11126,7 @@
                 </a:solidFill>
                 <a:latin typeface="Segoe UI"/>
               </a:rPr>
-              <a:t>33</a:t>
+              <a:t>44</a:t>
             </a:r>
           </a:p>
         </p:txBody>
@@ -9659,7 +11253,7 @@
                 </a:solidFill>
                 <a:latin typeface="Segoe UI"/>
               </a:rPr>
-              <a:t>43</a:t>
+              <a:t>49</a:t>
             </a:r>
           </a:p>
         </p:txBody>
@@ -10069,11 +11663,11 @@
           <a:p>
             <a:pPr>
               <a:spcAft>
-                <a:spcPts val="600"/>
+                <a:spcPts val="300"/>
               </a:spcAft>
             </a:pPr>
             <a:r>
-              <a:rPr sz="1400" b="1">
+              <a:rPr sz="1300" b="1">
                 <a:solidFill>
                   <a:srgbClr val="20243A"/>
                 </a:solidFill>
@@ -10082,7 +11676,7 @@
               <a:t>•  Project structure</a:t>
             </a:r>
             <a:r>
-              <a:rPr sz="1400">
+              <a:rPr sz="1300">
                 <a:solidFill>
                   <a:srgbClr val="737B91"/>
                 </a:solidFill>
@@ -10094,11 +11688,11 @@
           <a:p>
             <a:pPr>
               <a:spcAft>
-                <a:spcPts val="600"/>
+                <a:spcPts val="300"/>
               </a:spcAft>
             </a:pPr>
             <a:r>
-              <a:rPr sz="1400" b="1">
+              <a:rPr sz="1300" b="1">
                 <a:solidFill>
                   <a:srgbClr val="20243A"/>
                 </a:solidFill>
@@ -10107,23 +11701,23 @@
               <a:t>•  Database design</a:t>
             </a:r>
             <a:r>
-              <a:rPr sz="1400">
+              <a:rPr sz="1300">
                 <a:solidFill>
                   <a:srgbClr val="737B91"/>
                 </a:solidFill>
                 <a:latin typeface="Segoe UI"/>
               </a:rPr>
-              <a:t> 3 tables, schema script, validation</a:t>
+              <a:t> 4 tables, schema script, validation</a:t>
             </a:r>
           </a:p>
           <a:p>
             <a:pPr>
               <a:spcAft>
-                <a:spcPts val="600"/>
+                <a:spcPts val="300"/>
               </a:spcAft>
             </a:pPr>
             <a:r>
-              <a:rPr sz="1400" b="1">
+              <a:rPr sz="1300" b="1">
                 <a:solidFill>
                   <a:srgbClr val="20243A"/>
                 </a:solidFill>
@@ -10132,57 +11726,82 @@
               <a:t>•  Database connectivity</a:t>
             </a:r>
             <a:r>
-              <a:rPr sz="1400">
+              <a:rPr sz="1300">
                 <a:solidFill>
                   <a:srgbClr val="737B91"/>
                 </a:solidFill>
                 <a:latin typeface="Segoe UI"/>
               </a:rPr>
-              <a:t> JPA + MySQL, local and cloud</a:t>
+              <a:t> JPA + plain JDBC DAO, local and cloud</a:t>
             </a:r>
           </a:p>
           <a:p>
             <a:pPr>
               <a:spcAft>
-                <a:spcPts val="600"/>
+                <a:spcPts val="300"/>
               </a:spcAft>
             </a:pPr>
             <a:r>
-              <a:rPr sz="1400" b="1">
+              <a:rPr sz="1300" b="1">
                 <a:solidFill>
                   <a:srgbClr val="20243A"/>
                 </a:solidFill>
                 <a:latin typeface="Segoe UI"/>
               </a:rPr>
-              <a:t>•  UI/UX</a:t>
-            </a:r>
-            <a:r>
-              <a:rPr sz="1400">
+              <a:t>•  Servlet</a:t>
+            </a:r>
+            <a:r>
+              <a:rPr sz="1300">
                 <a:solidFill>
                   <a:srgbClr val="737B91"/>
                 </a:solidFill>
                 <a:latin typeface="Segoe UI"/>
               </a:rPr>
-              <a:t> consistent design, responsive layout</a:t>
+              <a:t> ExportServlet for CSV downloads</a:t>
             </a:r>
           </a:p>
           <a:p>
             <a:pPr>
               <a:spcAft>
-                <a:spcPts val="600"/>
+                <a:spcPts val="300"/>
               </a:spcAft>
             </a:pPr>
             <a:r>
-              <a:rPr sz="1400" b="1">
+              <a:rPr sz="1300" b="1">
                 <a:solidFill>
                   <a:srgbClr val="20243A"/>
                 </a:solidFill>
                 <a:latin typeface="Segoe UI"/>
               </a:rPr>
+              <a:t>•  UI/UX</a:t>
+            </a:r>
+            <a:r>
+              <a:rPr sz="1300">
+                <a:solidFill>
+                  <a:srgbClr val="737B91"/>
+                </a:solidFill>
+                <a:latin typeface="Segoe UI"/>
+              </a:rPr>
+              <a:t> consistent design, responsive layout</a:t>
+            </a:r>
+          </a:p>
+          <a:p>
+            <a:pPr>
+              <a:spcAft>
+                <a:spcPts val="300"/>
+              </a:spcAft>
+            </a:pPr>
+            <a:r>
+              <a:rPr sz="1300" b="1">
+                <a:solidFill>
+                  <a:srgbClr val="20243A"/>
+                </a:solidFill>
+                <a:latin typeface="Segoe UI"/>
+              </a:rPr>
               <a:t>•  Extra</a:t>
             </a:r>
             <a:r>
-              <a:rPr sz="1400">
+              <a:rPr sz="1300">
                 <a:solidFill>
                   <a:srgbClr val="737B91"/>
                 </a:solidFill>

</xml_diff>